<commit_message>
Put Mina's research plan first: baselines and datasets before Coupled Mamba and cross-attention; resync Gantt, notes, deck, figures and READMEs
</commit_message>
<xml_diff>
--- a/docs/notes/Slides/Mina_Meeting_Slides_2026-10-20.pptx
+++ b/docs/notes/Slides/Mina_Meeting_Slides_2026-10-20.pptx
@@ -16,9 +16,9 @@
     <p:sldId id="264" r:id="rId10"/>
     <p:sldId id="265" r:id="rId11"/>
     <p:sldId id="266" r:id="rId12"/>
-    <p:sldId id="267" r:id="rId13"/>
     <p:sldId id="268" r:id="rId14"/>
     <p:sldId id="269" r:id="rId15"/>
+    <p:sldId id="267" r:id="rId13"/>
     <p:sldId id="270" r:id="rId16"/>
     <p:sldId id="271" r:id="rId17"/>
     <p:sldId id="272" r:id="rId18"/>
@@ -695,7 +695,7 @@
           <a:p>
             <a:r>
               <a:rPr lang="en-US" dirty="0"/>
-              <a:t>Before the design slides, the two stages in one picture. Stage 3 is the build: which fusion architectures we train. Concatenation plus an MLP is the floor; Coupled Mamba is our first choice on coding sequence and cross-attention second, for GTEx where there is no shared grid. Items one and two of Mina's research plan add two baselines here, a faithful reproduction of BioLangFusion and LucaOne, which is jointly pretrained. Stage 4 is the test: the hypotheses, the baselines every result has to clear, the datasets, the ablations, and the method test, which asks whether the cheap Stage 1 measurements predict where fusion helps. The rest of her seven items land in Stage 4, in her order and under her numbers. The next slide is Stage 3; everything after it is Stage 4.</a:t>
+              <a:t>Before the design slides, the two stages in one picture. Stage 3 is the build: which fusion architectures we train. Mina's research plan comes first: items one and two are baselines built before anything of ours, a faithful reproduction of BioLangFusion with its encoders then swapped, and LucaOne, which is jointly pretrained, with IsoFormer reproduced on GTEx beside them. Concatenation plus an MLP is the floor. Then, from January, our designs: Coupled Mamba on coding sequence first and cross-attention second, for GTEx where there is no shared grid. Stage 4 is the test: the hypotheses, the baselines every result has to clear, the datasets, the ablations, and the method test, which asks whether the cheap Stage 1 measurements predict where fusion helps. The rest of her seven items land in Stage 4, in her order and under her numbers, and her datasets are in place before our designs are trained. The next two slides are her plan; then our two designs; then how everything is tested.</a:t>
             </a:r>
             <a:endParaRPr lang="en-US" dirty="0"/>
           </a:p>
@@ -783,7 +783,7 @@
           <a:p>
             <a:r>
               <a:rPr lang="en-US" dirty="0"/>
-              <a:t>Stage 3 is unchanged: it turns the Stage 2 decision into trainable modules over token-level embeddings. Concatenation plus an MLP is the reference every fusion model must beat. Coupled Mamba is the priority architecture on coding sequence, agreed in September: one recurrent chain per modality, coupled at every codon step, so the modalities exchange information without any term that makes them look alike, linear in sequence length. IsoFormer-style cross-attention is second, for GTEx where there is no grid, and the benchmark competitor on stability. What the research plan adds is the baseline these are scored against. From the next slide on, we are in Stage 4: how all of this gets tested.</a:t>
+              <a:t>Our two designs come after the research plan's baselines and datasets, from January; the designs themselves are unchanged: they turn the Stage 2 decision into trainable modules over token-level embeddings. Concatenation plus an MLP is the reference every fusion model must beat. Coupled Mamba is our first design on coding sequence, agreed in September: one recurrent chain per modality, coupled at every codon step, so the modalities exchange information without any term that makes them look alike, linear in sequence length. IsoFormer-style cross-attention is second, for GTEx where there is no grid, and the benchmark competitor on stability. Everything from her plan, the reproduced heads, the swaps, LucaOne, and IsoFormer, is what these are scored against. From the next slide on, we are in Stage 4: how all of this gets tested.</a:t>
             </a:r>
             <a:endParaRPr lang="en-US" dirty="0"/>
           </a:p>
@@ -871,7 +871,7 @@
           <a:p>
             <a:r>
               <a:rPr lang="en-US" dirty="0"/>
-              <a:t>These are the seven items from Mina's research plan, in her order and under her numbers, placed on the design from the previous slide. Item one, Phase A, widens the matched BioLangFusion comparison in the Gantt chart, ID 17, now October 12 to 25, to a faithful reproduction on all five of its published datasets, and that reproduction becomes the matched baseline Coupled Mamba is scored against; Phase B, the encoder swaps on Fungal, E. coli, mRNA stability, and Ab1, with CoV-Vac if feasible, follows directly as ID 24, October 26 to November 8. Item two is LucaOne as a jointly pretrained baseline, the new row 41, November 9 to 22, after the swaps, which is the order her plan sets. Items three and four are half-life and translation efficiency on the mRNABench splits, row 42 in January and February after their gates, earlier if cluster time allows. Item five, the mRFP control, runs in parallel, in the controls of ID 18. Item six, structure, is conditional in ID 38. Item seven, distillation, is to think about, not build; it has its own row, 43, after the core comparisons. Dates are as of October 15 and will move.</a:t>
+              <a:t>These are the seven items from Mina's research plan, in her order and under her numbers, and they come before anything of ours. Item one, Phase A, widens the matched BioLangFusion comparison in the Gantt chart, ID 17, now October 12 to 25, to a faithful reproduction on all five of its published datasets, and that reproduction becomes the matched baseline Coupled Mamba is scored against; Phase B, the encoder swaps on Fungal, E. coli, mRNA stability, and Ab1, with CoV-Vac if feasible, follows directly as ID 24, October 26 to November 8. Item two is LucaOne as a jointly pretrained baseline, the new row 41, November 9 to 22, after the swaps, which is the order her plan sets. Items three and four are half-life and translation efficiency on the mRNABench splits, row 42, November 23 to December 20, after their gates. IsoFormer is reproduced on GTEx beside LucaOne as row 44. Only then, from January, do Coupled Mamba and cross-attention get trained, scored against all of these. Item five, the mRFP control, runs in parallel, in the controls of ID 18. Item six, structure, is conditional in ID 38, in March. Item seven, distillation, is to think about, not build; it has its own row, 43, in March, after the core comparisons and our designs. Dates are as of October 15 and will move.</a:t>
             </a:r>
             <a:endParaRPr lang="en-US" dirty="0"/>
           </a:p>
@@ -959,7 +959,7 @@
           <a:p>
             <a:r>
               <a:rPr lang="en-US" dirty="0"/>
-              <a:t>Panel a is item one of the research plan. Solid boxes are BioLangFusion's own encoders; the dashed boxes under them are the Stage 1 candidates we swap in during Phase B, on Fungal, E. coli, mRNA stability, and Ab1, with CoV-Vac if feasible, one at a time, holding the grid, the three heads, the TextCNN head, the splits, and the evaluation fixed. Panel b is what we do where no global grid exists: pool each stream, the transcript by region, concatenate or gate, and always report the length and composition baseline beside it. Panel c is what everything is compared with: LucaOne, item two, as the jointly pretrained alternative, and our own Stage 3 designs, which go into the same pipeline as a fourth head so their gain over the reproduced heads is measured on identical samples and splits.</a:t>
+              <a:t>Panel a is item one of the research plan. Solid boxes are BioLangFusion's own encoders; the dashed boxes under them are the Stage 1 candidates we swap in during Phase B, on Fungal, E. coli, mRNA stability, and Ab1, with CoV-Vac if feasible, one at a time, holding the grid, the three heads, the TextCNN head, the splits, and the evaluation fixed. Panel b is what we do where no global grid exists: pool each stream, the transcript by region, concatenate or gate, and always report the length and composition baseline beside it. Panel c is what everything is compared with: LucaOne, item two, as the jointly pretrained alternative, and our own Stage 3 designs, which come later, from January, and go into the same pipeline as a fourth head so their gain over the reproduced heads is measured on identical samples and splits.</a:t>
             </a:r>
             <a:endParaRPr lang="en-US" dirty="0"/>
           </a:p>
@@ -1223,7 +1223,7 @@
           <a:p>
             <a:r>
               <a:rPr lang="en-US" dirty="0"/>
-              <a:t>This is the exploratory idea at the end of the plan, item seven, and the ask was to think about it, not build it. The plan sets six DNA, five RNA, and four protein teachers; we have four of each from Stage 1, so two DNA encoders and one RNA encoder join as teachers only, and Stage 1 stays as it is. The mechanism: each frozen teacher gives a batch-by-batch similarity matrix between sequences, and a small student with one projection per teacher learns to reproduce those matrices; then the three students are frozen and fused. Our Stage 1 measurements are directly about those similarity matrices, so we can already say three things. Most of what a DNA teacher's matrix contains is composition, so beside the plan's raw target we report the composition-controlled one, or we cannot tell whether the student learned more than counts. Several teachers carry the same structure, so equal weights double-count them, which the plan's uniform baseline will show. And a sequence-level loss cannot keep the codon-level detail that made the codon encoders useful; the plan allows a token-level term where it is justified. We would run it as written, RNA first as in her worked example, after the core comparisons in Gantt 43, and evaluate on the five BioLangFusion sets with the reproduced heads so the deltas line up with Phase B.</a:t>
+              <a:t>This is the exploratory idea at the end of the plan, item seven, and the ask was to think about it, not build it. The plan sets six DNA, five RNA, and four protein teachers; we have four of each from Stage 1, so two DNA encoders and one RNA encoder join as teachers only, and Stage 1 stays as it is. The mechanism: each frozen teacher gives a batch-by-batch similarity matrix between sequences, and a small student with one projection per teacher learns to reproduce those matrices; then the three students are frozen and fused. Our Stage 1 measurements are directly about those similarity matrices, so we can already say three things. Most of what a DNA teacher's matrix contains is composition, so beside the plan's raw target we report the composition-controlled one, or we cannot tell whether the student learned more than counts. Several teachers carry the same structure, so equal weights double-count them, which the plan's uniform baseline will show. And a sequence-level loss cannot keep the codon-level detail that made the codon encoders useful; the plan allows a token-level term where it is justified. We would run it as written, RNA first as in her worked example, after the core comparisons and our designs, in Gantt 43 in March, and evaluate on the five BioLangFusion sets with the reproduced heads so the deltas line up with Phase B.</a:t>
             </a:r>
             <a:endParaRPr lang="en-US" dirty="0"/>
           </a:p>
@@ -1311,7 +1311,7 @@
           <a:p>
             <a:r>
               <a:rPr lang="en-US" dirty="0"/>
-              <a:t>The left column is our Gantt chart with the research plan's seven items folded into the existing IDs and the new rows 41 to 43; Coupled Mamba keeps its slot. The right column is where your answer changes what we build. The first is the framing question for the paper. The second matters before any training: we could not verify an official code release, so Phase A is a reimplementation from the paper, and we want to agree on which unreported details to fix and flag. The third is the Gantt question: we fold her items into the existing IDs and three new rows rather than reorder the plan, and we want to agree the placement before the dates move. The fourth is the LucaOne truncation policy, which decides what its comparison means on long sequences. The fifth is the distillation idea: her plan sets six DNA, five RNA, and four protein teachers and we have four of each, so we need to know which two DNA encoders and which RNA encoder to add.</a:t>
+              <a:t>The left column is our Gantt chart with your research plan first: its baselines and datasets run through December 20, with IsoFormer added beside LucaOne as row 44, and Coupled Mamba and cross-attention follow from January. The right column is where your answer changes what we build. The first is the framing question for the paper. The second matters before any training: we could not verify an official code release, so Phase A is a reimplementation from the paper, and we want to agree on which unreported details to fix and flag. The third is the Gantt question: we moved her items ahead of our own designs, and we want to agree the placement before the dates move. The fourth is the LucaOne truncation policy, which decides what its comparison means on long sequences. The fifth is the distillation idea: her plan sets six DNA, five RNA, and four protein teachers and we have four of each, so we need to know which two DNA encoders and which RNA encoder to add.</a:t>
             </a:r>
             <a:endParaRPr lang="en-US" dirty="0"/>
           </a:p>
@@ -1487,7 +1487,7 @@
           <a:p>
             <a:r>
               <a:rPr lang="en-US" dirty="0"/>
-              <a:t>Before the findings, the whole project on one slide, because every later slide is a step in this chain. Stage 1 asked what each frozen encoder carries and how the twelve spaces relate; its four findings force Stage 2, a biology-specific definition of alignment, because the usual ML meaning would mislead. Stage 2's decision, no alignment loss and a grid only on coding sequence, forces Stage 3's designs: architectures that let modalities interact without forcing similarity, scored against the published system reproduced exactly. Stage 4 tests whether fusion helps, for which task, and whether Stage 1 could have told us in advance. Mina's research plan and the October papers are placed in this chain rather than beside it: her items one and two, the reproduction and LucaOne, are the baselines in Stage 3; the encoder swaps of item one and items three to seven are Stage 4; and Fusion or Confusion gives the evaluation rules on every comparison.</a:t>
+              <a:t>Before the findings, the whole project on one slide, because every later slide is a step in this chain. Stage 1 asked what each frozen encoder carries and how the twelve spaces relate; its four findings force Stage 2, a biology-specific definition of alignment, because the usual ML meaning would mislead. Stage 2's decision, no alignment loss and a grid only on coding sequence, forces Stage 3's designs: architectures that let modalities interact without forcing similarity, scored against the published system reproduced exactly. Stage 4 tests whether fusion helps, for which task, and whether Stage 1 could have told us in advance. Mina's research plan and the October papers are placed in this chain rather than beside it: her items one and two, the reproduction and LucaOne, are the baselines in Stage 3, built before our own designs; the encoder swaps of item one and items three to seven are Stage 4, with items one to five done first; and Fusion or Confusion gives the evaluation rules on every comparison.</a:t>
             </a:r>
             <a:endParaRPr lang="en-US" dirty="0"/>
           </a:p>
@@ -3197,6 +3197,10 @@
             <a:prstDash val="solid"/>
           </a:ln>
         </p:spPr>
+        <p:txBody>
+          <a:bodyPr/>
+          <a:p/>
+        </p:txBody>
       </p:sp>
       <p:graphicFrame>
         <p:nvGraphicFramePr>
@@ -4483,6 +4487,10 @@
             <a:prstDash val="solid"/>
           </a:ln>
         </p:spPr>
+        <p:txBody>
+          <a:bodyPr/>
+          <a:p/>
+        </p:txBody>
       </p:sp>
       <p:sp>
         <p:nvSpPr>
@@ -4611,7 +4619,7 @@
                 <a:ea typeface="Inter" pitchFamily="34" charset="-122"/>
                 <a:cs typeface="Inter" pitchFamily="34" charset="-120"/>
               </a:rPr>
-              <a:t>Floor:</a:t>
+              <a:t>Research plan first:</a:t>
             </a:r>
             <a:r>
               <a:rPr lang="en-US" sz="1250" dirty="0">
@@ -4622,7 +4630,7 @@
                 <a:ea typeface="Inter" pitchFamily="34" charset="-122"/>
                 <a:cs typeface="Inter" pitchFamily="34" charset="-120"/>
               </a:rPr>
-              <a:t> concatenation + MLP, which every model must beat</a:t>
+              <a:t> BioLangFusion reproduced exactly, then encoder swaps (1); LucaOne (2); IsoFormer on GTEx</a:t>
             </a:r>
             <a:endParaRPr lang="en-US" sz="1250" dirty="0"/>
           </a:p>
@@ -4643,7 +4651,7 @@
                 <a:ea typeface="Inter" pitchFamily="34" charset="-122"/>
                 <a:cs typeface="Inter" pitchFamily="34" charset="-120"/>
               </a:rPr>
-              <a:t>Architecture priority 1:</a:t>
+              <a:t>Floor:</a:t>
             </a:r>
             <a:r>
               <a:rPr lang="en-US" sz="1250" dirty="0">
@@ -4654,7 +4662,7 @@
                 <a:ea typeface="Inter" pitchFamily="34" charset="-122"/>
                 <a:cs typeface="Inter" pitchFamily="34" charset="-120"/>
               </a:rPr>
-              <a:t> Coupled Mamba on the codon grid (coding sequence)</a:t>
+              <a:t> concatenation + MLP, which every model must beat</a:t>
             </a:r>
             <a:endParaRPr lang="en-US" sz="1250" dirty="0"/>
           </a:p>
@@ -4675,7 +4683,7 @@
                 <a:ea typeface="Inter" pitchFamily="34" charset="-122"/>
                 <a:cs typeface="Inter" pitchFamily="34" charset="-120"/>
               </a:rPr>
-              <a:t>Architecture priority 2:</a:t>
+              <a:t>Then design 1, from January:</a:t>
             </a:r>
             <a:r>
               <a:rPr lang="en-US" sz="1250" dirty="0">
@@ -4686,7 +4694,7 @@
                 <a:ea typeface="Inter" pitchFamily="34" charset="-122"/>
                 <a:cs typeface="Inter" pitchFamily="34" charset="-120"/>
               </a:rPr>
-              <a:t> IsoFormer-style cross-attention (GTEx, no grid)</a:t>
+              <a:t> Coupled Mamba on the codon grid (coding sequence)</a:t>
             </a:r>
             <a:endParaRPr lang="en-US" sz="1250" dirty="0"/>
           </a:p>
@@ -4707,7 +4715,7 @@
                 <a:ea typeface="Inter" pitchFamily="34" charset="-122"/>
                 <a:cs typeface="Inter" pitchFamily="34" charset="-120"/>
               </a:rPr>
-              <a:t>Research plan items 1 and 2:</a:t>
+              <a:t>Then design 2:</a:t>
             </a:r>
             <a:r>
               <a:rPr lang="en-US" sz="1250" dirty="0">
@@ -4718,7 +4726,7 @@
                 <a:ea typeface="Inter" pitchFamily="34" charset="-122"/>
                 <a:cs typeface="Inter" pitchFamily="34" charset="-120"/>
               </a:rPr>
-              <a:t> BioLangFusion reproduced exactly; LucaOne</a:t>
+              <a:t> IsoFormer-style cross-attention (GTEx, no grid)</a:t>
             </a:r>
             <a:endParaRPr lang="en-US" sz="1250" dirty="0"/>
           </a:p>
@@ -4789,6 +4797,10 @@
           </a:solidFill>
           <a:ln/>
         </p:spPr>
+        <p:txBody>
+          <a:bodyPr/>
+          <a:p/>
+        </p:txBody>
       </p:sp>
       <p:sp>
         <p:nvSpPr>
@@ -5047,7 +5059,7 @@
                 <a:ea typeface="Inter" pitchFamily="34" charset="-122"/>
                 <a:cs typeface="Inter" pitchFamily="34" charset="-120"/>
               </a:rPr>
-              <a:t>Research plan items:</a:t>
+              <a:t>Research plan first:</a:t>
             </a:r>
             <a:r>
               <a:rPr lang="en-US" sz="1250" dirty="0">
@@ -5058,7 +5070,7 @@
                 <a:ea typeface="Inter" pitchFamily="34" charset="-122"/>
                 <a:cs typeface="Inter" pitchFamily="34" charset="-120"/>
               </a:rPr>
-              <a:t> encoder swaps (1), half-life (3), translation efficiency (4), mRFP control (5), structure (6), distillation (7)</a:t>
+              <a:t> half-life (3), translation efficiency (4), and the mRFP control (5) before our designs; structure (6) and distillation (7) after</a:t>
             </a:r>
             <a:endParaRPr lang="en-US" sz="1250" dirty="0"/>
           </a:p>
@@ -5073,6 +5085,740 @@
 </file>
 
 <file path=ppt/slides/slide12.xml><?xml version="1.0" encoding="utf-8"?>
+<p:sld xmlns:a="http://schemas.openxmlformats.org/drawingml/2006/main" xmlns:r="http://schemas.openxmlformats.org/officeDocument/2006/relationships" xmlns:p="http://schemas.openxmlformats.org/presentationml/2006/main">
+  <p:cSld name="Slide 13">
+    <p:bg>
+      <p:bgPr>
+        <a:solidFill>
+          <a:srgbClr val="F6F5F4"/>
+        </a:solidFill>
+      </p:bgPr>
+    </p:bg>
+    <p:spTree>
+      <p:nvGrpSpPr>
+        <p:cNvPr id="1" name=""/>
+        <p:cNvGrpSpPr/>
+        <p:nvPr/>
+      </p:nvGrpSpPr>
+      <p:grpSpPr>
+        <a:xfrm>
+          <a:off x="0" y="0"/>
+          <a:ext cx="0" cy="0"/>
+          <a:chOff x="0" y="0"/>
+          <a:chExt cx="0" cy="0"/>
+        </a:xfrm>
+      </p:grpSpPr>
+      <p:pic>
+        <p:nvPicPr>
+          <p:cNvPr id="2" name="Image 0" descr="ellipse">    </p:cNvPr>
+          <p:cNvPicPr>
+            <a:picLocks noChangeAspect="1"/>
+          </p:cNvPicPr>
+          <p:nvPr/>
+        </p:nvPicPr>
+        <p:blipFill>
+          <a:blip r:embed="rId1"/>
+          <a:srcRect l="0" r="0" t="0" b="0"/>
+          <a:stretch/>
+        </p:blipFill>
+        <p:spPr>
+          <a:xfrm>
+            <a:off x="812800" y="862310"/>
+            <a:ext cx="114300" cy="114300"/>
+          </a:xfrm>
+          <a:prstGeom prst="rect">
+            <a:avLst/>
+          </a:prstGeom>
+        </p:spPr>
+      </p:pic>
+      <p:sp>
+        <p:nvSpPr>
+          <p:cNvPr id="3" name="Text 0"/>
+          <p:cNvSpPr/>
+          <p:nvPr/>
+        </p:nvSpPr>
+        <p:spPr>
+          <a:xfrm>
+            <a:off x="1003300" y="812800"/>
+            <a:ext cx="3326547" cy="238720"/>
+          </a:xfrm>
+          <a:prstGeom prst="rect">
+            <a:avLst/>
+          </a:prstGeom>
+          <a:noFill/>
+          <a:ln/>
+        </p:spPr>
+        <p:txBody>
+          <a:bodyPr wrap="square" lIns="0" tIns="0" rIns="0" bIns="0" rtlCol="0" anchor="t">
+            <a:normAutofit/>
+          </a:bodyPr>
+          <a:lstStyle/>
+          <a:p>
+            <a:pPr algn="l" indent="0" marL="0">
+              <a:lnSpc>
+                <a:spcPts val="1680"/>
+              </a:lnSpc>
+              <a:buNone/>
+            </a:pPr>
+            <a:r>
+              <a:rPr lang="en-US" sz="1200" b="1" dirty="0">
+                <a:solidFill>
+                  <a:srgbClr val="615D59"/>
+                </a:solidFill>
+                <a:latin typeface="Inter" pitchFamily="34" charset="0"/>
+                <a:ea typeface="Inter" pitchFamily="34" charset="-122"/>
+                <a:cs typeface="Inter" pitchFamily="34" charset="-120"/>
+              </a:rPr>
+              <a:t>Stage 4 · the research plan first</a:t>
+            </a:r>
+            <a:endParaRPr lang="en-US" sz="1200" dirty="0"/>
+          </a:p>
+        </p:txBody>
+      </p:sp>
+      <p:sp>
+        <p:nvSpPr>
+          <p:cNvPr id="4" name="Text 1"/>
+          <p:cNvSpPr/>
+          <p:nvPr>
+            <p:ph type="title"/>
+          </p:nvPr>
+        </p:nvSpPr>
+        <p:spPr>
+          <a:xfrm>
+            <a:off x="812800" y="1153120"/>
+            <a:ext cx="10883392" cy="806152"/>
+          </a:xfrm>
+          <a:prstGeom prst="rect">
+            <a:avLst/>
+          </a:prstGeom>
+          <a:noFill/>
+          <a:ln/>
+        </p:spPr>
+        <p:txBody>
+          <a:bodyPr wrap="square" lIns="0" tIns="0" rIns="0" bIns="0" rtlCol="0" anchor="t">
+            <a:normAutofit/>
+          </a:bodyPr>
+          <a:lstStyle/>
+          <a:p>
+            <a:pPr algn="l" indent="0" marL="0">
+              <a:lnSpc>
+                <a:spcPts val="3074"/>
+              </a:lnSpc>
+              <a:buNone/>
+            </a:pPr>
+            <a:r>
+              <a:rPr lang="en-US" sz="2900" b="1" i="0" spc="-100" kern="0" dirty="0">
+                <a:solidFill>
+                  <a:srgbClr val="000000"/>
+                </a:solidFill>
+                <a:latin typeface="Inter" pitchFamily="34" charset="0"/>
+                <a:ea typeface="Inter" pitchFamily="34" charset="-122"/>
+                <a:cs typeface="Inter" pitchFamily="34" charset="-120"/>
+              </a:rPr>
+              <a:t>The research plan's seven items, in its order, each with a place in the tiers and the Gantt chart</a:t>
+            </a:r>
+            <a:endParaRPr lang="en-US" sz="2900" dirty="0"/>
+          </a:p>
+        </p:txBody>
+      </p:sp>
+      <p:sp>
+        <p:nvSpPr>
+          <p:cNvPr id="5" name="Shape 2"/>
+          <p:cNvSpPr/>
+          <p:nvPr/>
+        </p:nvSpPr>
+        <p:spPr>
+          <a:xfrm>
+            <a:off x="1546225" y="2064048"/>
+            <a:ext cx="9099550" cy="3746500"/>
+          </a:xfrm>
+          <a:prstGeom prst="roundRect">
+            <a:avLst>
+              <a:gd name="adj" fmla="val 2627"/>
+            </a:avLst>
+          </a:prstGeom>
+          <a:solidFill>
+            <a:srgbClr val="FFFFFF"/>
+          </a:solidFill>
+          <a:ln w="6350">
+            <a:solidFill>
+              <a:srgbClr val="E6E6E6"/>
+            </a:solidFill>
+            <a:prstDash val="solid"/>
+          </a:ln>
+        </p:spPr>
+        <p:txBody>
+          <a:bodyPr/>
+          <a:p/>
+        </p:txBody>
+      </p:sp>
+      <p:sp>
+        <p:nvSpPr>
+          <p:cNvPr id="6" name="Shape 3"/>
+          <p:cNvSpPr/>
+          <p:nvPr/>
+        </p:nvSpPr>
+        <p:spPr>
+          <a:xfrm>
+            <a:off x="1651000" y="2143423"/>
+            <a:ext cx="8890000" cy="3587750"/>
+          </a:xfrm>
+          <a:prstGeom prst="roundRect">
+            <a:avLst>
+              <a:gd name="adj" fmla="val 1416"/>
+            </a:avLst>
+          </a:prstGeom>
+          <a:solidFill>
+            <a:srgbClr val="FFFFFF"/>
+          </a:solidFill>
+          <a:ln/>
+        </p:spPr>
+        <p:txBody>
+          <a:bodyPr/>
+          <a:p/>
+        </p:txBody>
+      </p:sp>
+      <p:pic>
+        <p:nvPicPr>
+          <p:cNvPr id="7" name="Image 1" descr="The research plan's seven items: BioLangFusion reproduction and encoder swaps, LucaOne, half-life, translation efficiency, the mRFP control, structure features, and the distillation idea, each with its Gantt slot">    </p:cNvPr>
+          <p:cNvPicPr>
+            <a:picLocks noChangeAspect="1"/>
+          </p:cNvPicPr>
+          <p:nvPr/>
+        </p:nvPicPr>
+        <p:blipFill>
+          <a:blip r:embed="rId2"/>
+          <a:srcRect l="0" r="0" t="-62" b="-62"/>
+          <a:stretch/>
+        </p:blipFill>
+        <p:spPr>
+          <a:xfrm>
+            <a:off x="1651000" y="2143423"/>
+            <a:ext cx="8890000" cy="3587750"/>
+          </a:xfrm>
+          <a:prstGeom prst="roundRect">
+            <a:avLst>
+              <a:gd name="adj" fmla="val 1416"/>
+            </a:avLst>
+          </a:prstGeom>
+        </p:spPr>
+      </p:pic>
+      <p:sp>
+        <p:nvSpPr>
+          <p:cNvPr id="8" name="Text 4"/>
+          <p:cNvSpPr/>
+          <p:nvPr/>
+        </p:nvSpPr>
+        <p:spPr>
+          <a:xfrm>
+            <a:off x="812800" y="6024959"/>
+            <a:ext cx="10883392" cy="452041"/>
+          </a:xfrm>
+          <a:prstGeom prst="rect">
+            <a:avLst/>
+          </a:prstGeom>
+          <a:noFill/>
+          <a:ln/>
+        </p:spPr>
+        <p:txBody>
+          <a:bodyPr wrap="square" lIns="0" tIns="0" rIns="0" bIns="0" rtlCol="0" anchor="t">
+            <a:normAutofit/>
+          </a:bodyPr>
+          <a:lstStyle/>
+          <a:p>
+            <a:pPr algn="l" indent="0" marL="0">
+              <a:lnSpc>
+                <a:spcPts val="1680"/>
+              </a:lnSpc>
+              <a:buNone/>
+            </a:pPr>
+            <a:r>
+              <a:rPr lang="en-US" sz="1200" dirty="0">
+                <a:solidFill>
+                  <a:srgbClr val="615D59"/>
+                </a:solidFill>
+                <a:latin typeface="Inter" pitchFamily="34" charset="0"/>
+                <a:ea typeface="Inter" pitchFamily="34" charset="-122"/>
+                <a:cs typeface="Inter" pitchFamily="34" charset="-120"/>
+              </a:rPr>
+              <a:t>Items 1 to 5 come first, with IsoFormer on GTEx beside LucaOne; Coupled Mamba and cross-attention follow from January and are scored against all of them. Items 6 and 7 come last.</a:t>
+            </a:r>
+            <a:endParaRPr lang="en-US" sz="1200" dirty="0"/>
+          </a:p>
+        </p:txBody>
+      </p:sp>
+    </p:spTree>
+  </p:cSld>
+  <p:clrMapOvr>
+    <a:masterClrMapping/>
+  </p:clrMapOvr>
+</p:sld>
+</file>
+
+<file path=ppt/slides/slide13.xml><?xml version="1.0" encoding="utf-8"?>
+<p:sld xmlns:a="http://schemas.openxmlformats.org/drawingml/2006/main" xmlns:r="http://schemas.openxmlformats.org/officeDocument/2006/relationships" xmlns:p="http://schemas.openxmlformats.org/presentationml/2006/main">
+  <p:cSld name="Slide 14">
+    <p:bg>
+      <p:bgPr>
+        <a:solidFill>
+          <a:srgbClr val="F6F5F4"/>
+        </a:solidFill>
+      </p:bgPr>
+    </p:bg>
+    <p:spTree>
+      <p:nvGrpSpPr>
+        <p:cNvPr id="1" name=""/>
+        <p:cNvGrpSpPr/>
+        <p:nvPr/>
+      </p:nvGrpSpPr>
+      <p:grpSpPr>
+        <a:xfrm>
+          <a:off x="0" y="0"/>
+          <a:ext cx="0" cy="0"/>
+          <a:chOff x="0" y="0"/>
+          <a:chExt cx="0" cy="0"/>
+        </a:xfrm>
+      </p:grpSpPr>
+      <p:pic>
+        <p:nvPicPr>
+          <p:cNvPr id="2" name="Image 0" descr="ellipse">    </p:cNvPr>
+          <p:cNvPicPr>
+            <a:picLocks noChangeAspect="1"/>
+          </p:cNvPicPr>
+          <p:nvPr/>
+        </p:nvPicPr>
+        <p:blipFill>
+          <a:blip r:embed="rId1"/>
+          <a:srcRect l="0" r="0" t="0" b="0"/>
+          <a:stretch/>
+        </p:blipFill>
+        <p:spPr>
+          <a:xfrm>
+            <a:off x="812800" y="862310"/>
+            <a:ext cx="114300" cy="114300"/>
+          </a:xfrm>
+          <a:prstGeom prst="rect">
+            <a:avLst/>
+          </a:prstGeom>
+        </p:spPr>
+      </p:pic>
+      <p:sp>
+        <p:nvSpPr>
+          <p:cNvPr id="3" name="Text 0"/>
+          <p:cNvSpPr/>
+          <p:nvPr/>
+        </p:nvSpPr>
+        <p:spPr>
+          <a:xfrm>
+            <a:off x="1003300" y="812800"/>
+            <a:ext cx="4694813" cy="238720"/>
+          </a:xfrm>
+          <a:prstGeom prst="rect">
+            <a:avLst/>
+          </a:prstGeom>
+          <a:noFill/>
+          <a:ln/>
+        </p:spPr>
+        <p:txBody>
+          <a:bodyPr wrap="square" lIns="0" tIns="0" rIns="0" bIns="0" rtlCol="0" anchor="t">
+            <a:normAutofit/>
+          </a:bodyPr>
+          <a:lstStyle/>
+          <a:p>
+            <a:pPr algn="l" indent="0" marL="0">
+              <a:lnSpc>
+                <a:spcPts val="1680"/>
+              </a:lnSpc>
+              <a:buNone/>
+            </a:pPr>
+            <a:r>
+              <a:rPr lang="en-US" sz="1200" b="1" dirty="0">
+                <a:solidFill>
+                  <a:srgbClr val="615D59"/>
+                </a:solidFill>
+                <a:latin typeface="Inter" pitchFamily="34" charset="0"/>
+                <a:ea typeface="Inter" pitchFamily="34" charset="-122"/>
+                <a:cs typeface="Inter" pitchFamily="34" charset="-120"/>
+              </a:rPr>
+              <a:t>Stages 3 and 4 · research plan item 1, Phases A and B</a:t>
+            </a:r>
+            <a:endParaRPr lang="en-US" sz="1200" dirty="0"/>
+          </a:p>
+        </p:txBody>
+      </p:sp>
+      <p:sp>
+        <p:nvSpPr>
+          <p:cNvPr id="4" name="Text 1"/>
+          <p:cNvSpPr/>
+          <p:nvPr>
+            <p:ph type="title"/>
+          </p:nvPr>
+        </p:nvSpPr>
+        <p:spPr>
+          <a:xfrm>
+            <a:off x="812800" y="1153120"/>
+            <a:ext cx="10883392" cy="806152"/>
+          </a:xfrm>
+          <a:prstGeom prst="rect">
+            <a:avLst/>
+          </a:prstGeom>
+          <a:noFill/>
+          <a:ln/>
+        </p:spPr>
+        <p:txBody>
+          <a:bodyPr wrap="square" lIns="0" tIns="0" rIns="0" bIns="0" rtlCol="0" anchor="t">
+            <a:normAutofit/>
+          </a:bodyPr>
+          <a:lstStyle/>
+          <a:p>
+            <a:pPr algn="l" indent="0" marL="0">
+              <a:lnSpc>
+                <a:spcPts val="3074"/>
+              </a:lnSpc>
+              <a:buNone/>
+            </a:pPr>
+            <a:r>
+              <a:rPr lang="en-US" sz="2900" b="1" i="0" spc="-100" kern="0" dirty="0">
+                <a:solidFill>
+                  <a:srgbClr val="000000"/>
+                </a:solidFill>
+                <a:latin typeface="Inter" pitchFamily="34" charset="0"/>
+                <a:ea typeface="Inter" pitchFamily="34" charset="-122"/>
+                <a:cs typeface="Inter" pitchFamily="34" charset="-120"/>
+              </a:rPr>
+              <a:t>Reproduce BioLangFusion exactly, then change the encoders and nothing else</a:t>
+            </a:r>
+            <a:endParaRPr lang="en-US" sz="2900" dirty="0"/>
+          </a:p>
+        </p:txBody>
+      </p:sp>
+      <p:sp>
+        <p:nvSpPr>
+          <p:cNvPr id="5" name="Shape 2"/>
+          <p:cNvSpPr/>
+          <p:nvPr/>
+        </p:nvSpPr>
+        <p:spPr>
+          <a:xfrm>
+            <a:off x="815975" y="2064048"/>
+            <a:ext cx="7296150" cy="3276600"/>
+          </a:xfrm>
+          <a:prstGeom prst="roundRect">
+            <a:avLst>
+              <a:gd name="adj" fmla="val 3004"/>
+            </a:avLst>
+          </a:prstGeom>
+          <a:solidFill>
+            <a:srgbClr val="FFFFFF"/>
+          </a:solidFill>
+          <a:ln w="6350">
+            <a:solidFill>
+              <a:srgbClr val="E6E6E6"/>
+            </a:solidFill>
+            <a:prstDash val="solid"/>
+          </a:ln>
+        </p:spPr>
+        <p:txBody>
+          <a:bodyPr/>
+          <a:p/>
+        </p:txBody>
+      </p:sp>
+      <p:sp>
+        <p:nvSpPr>
+          <p:cNvPr id="6" name="Shape 3"/>
+          <p:cNvSpPr/>
+          <p:nvPr/>
+        </p:nvSpPr>
+        <p:spPr>
+          <a:xfrm>
+            <a:off x="908050" y="2143423"/>
+            <a:ext cx="7112000" cy="3117850"/>
+          </a:xfrm>
+          <a:prstGeom prst="roundRect">
+            <a:avLst>
+              <a:gd name="adj" fmla="val 1629"/>
+            </a:avLst>
+          </a:prstGeom>
+          <a:solidFill>
+            <a:srgbClr val="FFFFFF"/>
+          </a:solidFill>
+          <a:ln/>
+        </p:spPr>
+        <p:txBody>
+          <a:bodyPr/>
+          <a:p/>
+        </p:txBody>
+      </p:sp>
+      <p:pic>
+        <p:nvPicPr>
+          <p:cNvPr id="7" name="Image 1" descr="The BioLangFusion architecture reproduced then run with swapped encoders; pooled or region-aware fusion where no grid exists; LucaOne and the Stage 3 designs it is compared with">    </p:cNvPr>
+          <p:cNvPicPr>
+            <a:picLocks noChangeAspect="1"/>
+          </p:cNvPicPr>
+          <p:nvPr/>
+        </p:nvPicPr>
+        <p:blipFill>
+          <a:blip r:embed="rId2"/>
+          <a:srcRect l="-23" r="-23" t="0" b="0"/>
+          <a:stretch/>
+        </p:blipFill>
+        <p:spPr>
+          <a:xfrm>
+            <a:off x="908050" y="2143423"/>
+            <a:ext cx="7112000" cy="3117850"/>
+          </a:xfrm>
+          <a:prstGeom prst="roundRect">
+            <a:avLst>
+              <a:gd name="adj" fmla="val 1629"/>
+            </a:avLst>
+          </a:prstGeom>
+        </p:spPr>
+      </p:pic>
+      <p:sp>
+        <p:nvSpPr>
+          <p:cNvPr id="8" name="Text 4"/>
+          <p:cNvSpPr/>
+          <p:nvPr/>
+        </p:nvSpPr>
+        <p:spPr>
+          <a:xfrm>
+            <a:off x="8270875" y="2064048"/>
+            <a:ext cx="3105150" cy="1136551"/>
+          </a:xfrm>
+          <a:prstGeom prst="roundRect">
+            <a:avLst>
+              <a:gd name="adj" fmla="val 6425"/>
+            </a:avLst>
+          </a:prstGeom>
+          <a:solidFill>
+            <a:srgbClr val="FFFFFF"/>
+          </a:solidFill>
+          <a:ln w="6350">
+            <a:solidFill>
+              <a:srgbClr val="E6E6E6"/>
+            </a:solidFill>
+            <a:prstDash val="solid"/>
+          </a:ln>
+        </p:spPr>
+        <p:txBody>
+          <a:bodyPr wrap="square" lIns="83387" tIns="57987" rIns="0" bIns="32587" rtlCol="0" anchor="t">
+            <a:normAutofit/>
+          </a:bodyPr>
+          <a:lstStyle/>
+          <a:p>
+            <a:pPr algn="l" indent="0" marL="0">
+              <a:lnSpc>
+                <a:spcPts val="1540"/>
+              </a:lnSpc>
+              <a:buNone/>
+            </a:pPr>
+            <a:r>
+              <a:rPr lang="en-US" sz="1100" b="1" dirty="0">
+                <a:solidFill>
+                  <a:srgbClr val="31302E"/>
+                </a:solidFill>
+                <a:latin typeface="Inter" pitchFamily="34" charset="0"/>
+                <a:ea typeface="Inter" pitchFamily="34" charset="-122"/>
+                <a:cs typeface="Inter" pitchFamily="34" charset="-120"/>
+              </a:rPr>
+              <a:t>Phase A, fixed:</a:t>
+            </a:r>
+            <a:r>
+              <a:rPr lang="en-US" sz="1100" dirty="0">
+                <a:solidFill>
+                  <a:srgbClr val="31302E"/>
+                </a:solidFill>
+                <a:latin typeface="Inter" pitchFamily="34" charset="0"/>
+                <a:ea typeface="Inter" pitchFamily="34" charset="-122"/>
+                <a:cs typeface="Inter" pitchFamily="34" charset="-120"/>
+              </a:rPr>
+              <a:t> NT v2 100M, RNA-FM, ESM-2 8M on the codon grid; the three heads; one TextCNN head; the CodonBERT splits and recipe; every unreported detail recorded as a deviation.</a:t>
+            </a:r>
+            <a:endParaRPr lang="en-US" sz="1100" dirty="0"/>
+          </a:p>
+        </p:txBody>
+      </p:sp>
+      <p:sp>
+        <p:nvSpPr>
+          <p:cNvPr id="9" name="Text 5"/>
+          <p:cNvSpPr/>
+          <p:nvPr/>
+        </p:nvSpPr>
+        <p:spPr>
+          <a:xfrm>
+            <a:off x="8270875" y="3283148"/>
+            <a:ext cx="3105150" cy="1136551"/>
+          </a:xfrm>
+          <a:prstGeom prst="roundRect">
+            <a:avLst>
+              <a:gd name="adj" fmla="val 6425"/>
+            </a:avLst>
+          </a:prstGeom>
+          <a:solidFill>
+            <a:srgbClr val="FFFFFF"/>
+          </a:solidFill>
+          <a:ln w="6350">
+            <a:solidFill>
+              <a:srgbClr val="E6E6E6"/>
+            </a:solidFill>
+            <a:prstDash val="solid"/>
+          </a:ln>
+        </p:spPr>
+        <p:txBody>
+          <a:bodyPr wrap="square" lIns="83387" tIns="57987" rIns="0" bIns="32587" rtlCol="0" anchor="t">
+            <a:normAutofit/>
+          </a:bodyPr>
+          <a:lstStyle/>
+          <a:p>
+            <a:pPr algn="l" indent="0" marL="0">
+              <a:lnSpc>
+                <a:spcPts val="1540"/>
+              </a:lnSpc>
+              <a:buNone/>
+            </a:pPr>
+            <a:r>
+              <a:rPr lang="en-US" sz="1100" b="1" dirty="0">
+                <a:solidFill>
+                  <a:srgbClr val="31302E"/>
+                </a:solidFill>
+                <a:latin typeface="Inter" pitchFamily="34" charset="0"/>
+                <a:ea typeface="Inter" pitchFamily="34" charset="-122"/>
+                <a:cs typeface="Inter" pitchFamily="34" charset="-120"/>
+              </a:rPr>
+              <a:t>Phase B, swapped one at a time:</a:t>
+            </a:r>
+            <a:r>
+              <a:rPr lang="en-US" sz="1100" dirty="0">
+                <a:solidFill>
+                  <a:srgbClr val="31302E"/>
+                </a:solidFill>
+                <a:latin typeface="Inter" pitchFamily="34" charset="0"/>
+                <a:ea typeface="Inter" pitchFamily="34" charset="-122"/>
+                <a:cs typeface="Inter" pitchFamily="34" charset="-120"/>
+              </a:rPr>
+              <a:t> CaLM or mRNA-FM for RNA-FM; ESM-2 150M or ProtBERT for ESM-2 8M; NT 500M, DNABERT-2, or HyenaDNA for NT v2. Then the promising triples.</a:t>
+            </a:r>
+            <a:endParaRPr lang="en-US" sz="1100" dirty="0"/>
+          </a:p>
+        </p:txBody>
+      </p:sp>
+      <p:sp>
+        <p:nvSpPr>
+          <p:cNvPr id="10" name="Text 6"/>
+          <p:cNvSpPr/>
+          <p:nvPr/>
+        </p:nvSpPr>
+        <p:spPr>
+          <a:xfrm>
+            <a:off x="8270875" y="4502249"/>
+            <a:ext cx="3105150" cy="1136551"/>
+          </a:xfrm>
+          <a:prstGeom prst="roundRect">
+            <a:avLst>
+              <a:gd name="adj" fmla="val 6425"/>
+            </a:avLst>
+          </a:prstGeom>
+          <a:solidFill>
+            <a:srgbClr val="FFFFFF"/>
+          </a:solidFill>
+          <a:ln w="6350">
+            <a:solidFill>
+              <a:srgbClr val="E6E6E6"/>
+            </a:solidFill>
+            <a:prstDash val="solid"/>
+          </a:ln>
+        </p:spPr>
+        <p:txBody>
+          <a:bodyPr wrap="square" lIns="83387" tIns="57987" rIns="0" bIns="32587" rtlCol="0" anchor="t">
+            <a:normAutofit/>
+          </a:bodyPr>
+          <a:lstStyle/>
+          <a:p>
+            <a:pPr algn="l" indent="0" marL="0">
+              <a:lnSpc>
+                <a:spcPts val="1540"/>
+              </a:lnSpc>
+              <a:buNone/>
+            </a:pPr>
+            <a:r>
+              <a:rPr lang="en-US" sz="1100" b="1" dirty="0">
+                <a:solidFill>
+                  <a:srgbClr val="31302E"/>
+                </a:solidFill>
+                <a:latin typeface="Inter" pitchFamily="34" charset="0"/>
+                <a:ea typeface="Inter" pitchFamily="34" charset="-122"/>
+                <a:cs typeface="Inter" pitchFamily="34" charset="-120"/>
+              </a:rPr>
+              <a:t>What it gives the plan:</a:t>
+            </a:r>
+            <a:r>
+              <a:rPr lang="en-US" sz="1100" dirty="0">
+                <a:solidFill>
+                  <a:srgbClr val="31302E"/>
+                </a:solidFill>
+                <a:latin typeface="Inter" pitchFamily="34" charset="0"/>
+                <a:ea typeface="Inter" pitchFamily="34" charset="-122"/>
+                <a:cs typeface="Inter" pitchFamily="34" charset="-120"/>
+              </a:rPr>
+              <a:t> a matched published baseline for Coupled Mamba on identical samples and splits, and the cleanest test of whether Stage 1 predicts which swaps gain (H2).</a:t>
+            </a:r>
+            <a:endParaRPr lang="en-US" sz="1100" dirty="0"/>
+          </a:p>
+        </p:txBody>
+      </p:sp>
+      <p:sp>
+        <p:nvSpPr>
+          <p:cNvPr id="11" name="Text 7"/>
+          <p:cNvSpPr/>
+          <p:nvPr/>
+        </p:nvSpPr>
+        <p:spPr>
+          <a:xfrm>
+            <a:off x="812800" y="6024959"/>
+            <a:ext cx="10883392" cy="452041"/>
+          </a:xfrm>
+          <a:prstGeom prst="rect">
+            <a:avLst/>
+          </a:prstGeom>
+          <a:noFill/>
+          <a:ln/>
+        </p:spPr>
+        <p:txBody>
+          <a:bodyPr wrap="square" lIns="0" tIns="0" rIns="0" bIns="0" rtlCol="0" anchor="t">
+            <a:normAutofit/>
+          </a:bodyPr>
+          <a:lstStyle/>
+          <a:p>
+            <a:pPr algn="l" indent="0" marL="0">
+              <a:lnSpc>
+                <a:spcPts val="1680"/>
+              </a:lnSpc>
+              <a:buNone/>
+            </a:pPr>
+            <a:r>
+              <a:rPr lang="en-US" sz="1200" dirty="0">
+                <a:solidFill>
+                  <a:srgbClr val="615D59"/>
+                </a:solidFill>
+                <a:latin typeface="Inter" pitchFamily="34" charset="0"/>
+                <a:ea typeface="Inter" pitchFamily="34" charset="-122"/>
+                <a:cs typeface="Inter" pitchFamily="34" charset="-120"/>
+              </a:rPr>
+              <a:t>The codon grid is positional alignment: a token-location operation, part of the reproduced system, not evidence that the embeddings carry the same information. Where no grid exists (GTEx, untranslated regions) fusion is pooled or region-aware.</a:t>
+            </a:r>
+            <a:endParaRPr lang="en-US" sz="1200" dirty="0"/>
+          </a:p>
+        </p:txBody>
+      </p:sp>
+    </p:spTree>
+  </p:cSld>
+  <p:clrMapOvr>
+    <a:masterClrMapping/>
+  </p:clrMapOvr>
+</p:sld>
+</file>
+
+<file path=ppt/slides/slide14.xml><?xml version="1.0" encoding="utf-8"?>
 <p:sld xmlns:a="http://schemas.openxmlformats.org/drawingml/2006/main" xmlns:r="http://schemas.openxmlformats.org/officeDocument/2006/relationships" xmlns:p="http://schemas.openxmlformats.org/presentationml/2006/main">
   <p:cSld name="Slide 12">
     <p:bg>
@@ -5157,7 +5903,7 @@
                 <a:ea typeface="Inter" pitchFamily="34" charset="-122"/>
                 <a:cs typeface="Inter" pitchFamily="34" charset="-120"/>
               </a:rPr>
-              <a:t>Stage 3 · fusion architecture design</a:t>
+              <a:t>Stage 3 · then our fusion designs</a:t>
             </a:r>
             <a:endParaRPr lang="en-US" sz="1200" dirty="0"/>
           </a:p>
@@ -5235,6 +5981,10 @@
             <a:prstDash val="solid"/>
           </a:ln>
         </p:spPr>
+        <p:txBody>
+          <a:bodyPr/>
+          <a:p/>
+        </p:txBody>
       </p:sp>
       <p:sp>
         <p:nvSpPr>
@@ -5244,8 +5994,8 @@
         </p:nvSpPr>
         <p:spPr>
           <a:xfrm>
-            <a:off x="1778000" y="1655266"/>
-            <a:ext cx="8636000" cy="3708400"/>
+            <a:off x="2511818" y="1655266"/>
+            <a:ext cx="7168364" cy="3081139"/>
           </a:xfrm>
           <a:prstGeom prst="roundRect">
             <a:avLst>
@@ -5257,6 +6007,10 @@
           </a:solidFill>
           <a:ln/>
         </p:spPr>
+        <p:txBody>
+          <a:bodyPr/>
+          <a:p/>
+        </p:txBody>
       </p:sp>
       <p:pic>
         <p:nvPicPr>
@@ -5273,8 +6027,8 @@
         </p:blipFill>
         <p:spPr>
           <a:xfrm>
-            <a:off x="1778000" y="1655266"/>
-            <a:ext cx="8636000" cy="3708400"/>
+            <a:off x="2511818" y="1655266"/>
+            <a:ext cx="7168364" cy="3081139"/>
           </a:xfrm>
           <a:prstGeom prst="roundRect">
             <a:avLst>
@@ -5309,6 +6063,10 @@
             <a:prstDash val="solid"/>
           </a:ln>
         </p:spPr>
+        <p:txBody>
+          <a:bodyPr/>
+          <a:p/>
+        </p:txBody>
       </p:sp>
       <p:sp>
         <p:nvSpPr>
@@ -5455,6 +6213,10 @@
             <a:prstDash val="solid"/>
           </a:ln>
         </p:spPr>
+        <p:txBody>
+          <a:bodyPr/>
+          <a:p/>
+        </p:txBody>
       </p:sp>
       <p:sp>
         <p:nvSpPr>
@@ -5494,7 +6256,7 @@
                 <a:ea typeface="Inter" pitchFamily="34" charset="-122"/>
                 <a:cs typeface="Inter" pitchFamily="34" charset="-120"/>
               </a:rPr>
-              <a:t>Coupled Mamba first (Gantt 20 to 21), cross-attention second (25);</a:t>
+              <a:t>After the research plan's baselines, from January:</a:t>
             </a:r>
             <a:r>
               <a:rPr lang="en-US" sz="1200" dirty="0">
@@ -5505,725 +6267,7 @@
                 <a:ea typeface="Inter" pitchFamily="34" charset="-122"/>
                 <a:cs typeface="Inter" pitchFamily="34" charset="-120"/>
               </a:rPr>
-              <a:t> both scored against the reproduced BioLangFusion heads on identical splits.</a:t>
-            </a:r>
-            <a:endParaRPr lang="en-US" sz="1200" dirty="0"/>
-          </a:p>
-        </p:txBody>
-      </p:sp>
-    </p:spTree>
-  </p:cSld>
-  <p:clrMapOvr>
-    <a:masterClrMapping/>
-  </p:clrMapOvr>
-</p:sld>
-</file>
-
-<file path=ppt/slides/slide13.xml><?xml version="1.0" encoding="utf-8"?>
-<p:sld xmlns:a="http://schemas.openxmlformats.org/drawingml/2006/main" xmlns:r="http://schemas.openxmlformats.org/officeDocument/2006/relationships" xmlns:p="http://schemas.openxmlformats.org/presentationml/2006/main">
-  <p:cSld name="Slide 13">
-    <p:bg>
-      <p:bgPr>
-        <a:solidFill>
-          <a:srgbClr val="F6F5F4"/>
-        </a:solidFill>
-      </p:bgPr>
-    </p:bg>
-    <p:spTree>
-      <p:nvGrpSpPr>
-        <p:cNvPr id="1" name=""/>
-        <p:cNvGrpSpPr/>
-        <p:nvPr/>
-      </p:nvGrpSpPr>
-      <p:grpSpPr>
-        <a:xfrm>
-          <a:off x="0" y="0"/>
-          <a:ext cx="0" cy="0"/>
-          <a:chOff x="0" y="0"/>
-          <a:chExt cx="0" cy="0"/>
-        </a:xfrm>
-      </p:grpSpPr>
-      <p:pic>
-        <p:nvPicPr>
-          <p:cNvPr id="2" name="Image 0" descr="ellipse">    </p:cNvPr>
-          <p:cNvPicPr>
-            <a:picLocks noChangeAspect="1"/>
-          </p:cNvPicPr>
-          <p:nvPr/>
-        </p:nvPicPr>
-        <p:blipFill>
-          <a:blip r:embed="rId1"/>
-          <a:srcRect l="0" r="0" t="0" b="0"/>
-          <a:stretch/>
-        </p:blipFill>
-        <p:spPr>
-          <a:xfrm>
-            <a:off x="812800" y="862310"/>
-            <a:ext cx="114300" cy="114300"/>
-          </a:xfrm>
-          <a:prstGeom prst="rect">
-            <a:avLst/>
-          </a:prstGeom>
-        </p:spPr>
-      </p:pic>
-      <p:sp>
-        <p:nvSpPr>
-          <p:cNvPr id="3" name="Text 0"/>
-          <p:cNvSpPr/>
-          <p:nvPr/>
-        </p:nvSpPr>
-        <p:spPr>
-          <a:xfrm>
-            <a:off x="1003300" y="812800"/>
-            <a:ext cx="3326547" cy="238720"/>
-          </a:xfrm>
-          <a:prstGeom prst="rect">
-            <a:avLst/>
-          </a:prstGeom>
-          <a:noFill/>
-          <a:ln/>
-        </p:spPr>
-        <p:txBody>
-          <a:bodyPr wrap="square" lIns="0" tIns="0" rIns="0" bIns="0" rtlCol="0" anchor="t">
-            <a:normAutofit/>
-          </a:bodyPr>
-          <a:lstStyle/>
-          <a:p>
-            <a:pPr algn="l" indent="0" marL="0">
-              <a:lnSpc>
-                <a:spcPts val="1680"/>
-              </a:lnSpc>
-              <a:buNone/>
-            </a:pPr>
-            <a:r>
-              <a:rPr lang="en-US" sz="1200" b="1" dirty="0">
-                <a:solidFill>
-                  <a:srgbClr val="615D59"/>
-                </a:solidFill>
-                <a:latin typeface="Inter" pitchFamily="34" charset="0"/>
-                <a:ea typeface="Inter" pitchFamily="34" charset="-122"/>
-                <a:cs typeface="Inter" pitchFamily="34" charset="-120"/>
-              </a:rPr>
-              <a:t>Stage 4 · what the research plan adds</a:t>
-            </a:r>
-            <a:endParaRPr lang="en-US" sz="1200" dirty="0"/>
-          </a:p>
-        </p:txBody>
-      </p:sp>
-      <p:sp>
-        <p:nvSpPr>
-          <p:cNvPr id="4" name="Text 1"/>
-          <p:cNvSpPr/>
-          <p:nvPr>
-            <p:ph type="title"/>
-          </p:nvPr>
-        </p:nvSpPr>
-        <p:spPr>
-          <a:xfrm>
-            <a:off x="812800" y="1153120"/>
-            <a:ext cx="10883392" cy="806152"/>
-          </a:xfrm>
-          <a:prstGeom prst="rect">
-            <a:avLst/>
-          </a:prstGeom>
-          <a:noFill/>
-          <a:ln/>
-        </p:spPr>
-        <p:txBody>
-          <a:bodyPr wrap="square" lIns="0" tIns="0" rIns="0" bIns="0" rtlCol="0" anchor="t">
-            <a:normAutofit/>
-          </a:bodyPr>
-          <a:lstStyle/>
-          <a:p>
-            <a:pPr algn="l" indent="0" marL="0">
-              <a:lnSpc>
-                <a:spcPts val="3074"/>
-              </a:lnSpc>
-              <a:buNone/>
-            </a:pPr>
-            <a:r>
-              <a:rPr lang="en-US" sz="2900" b="1" i="0" spc="-100" kern="0" dirty="0">
-                <a:solidFill>
-                  <a:srgbClr val="000000"/>
-                </a:solidFill>
-                <a:latin typeface="Inter" pitchFamily="34" charset="0"/>
-                <a:ea typeface="Inter" pitchFamily="34" charset="-122"/>
-                <a:cs typeface="Inter" pitchFamily="34" charset="-120"/>
-              </a:rPr>
-              <a:t>The research plan's seven items, in its order, each with a place in the tiers and the Gantt chart</a:t>
-            </a:r>
-            <a:endParaRPr lang="en-US" sz="2900" dirty="0"/>
-          </a:p>
-        </p:txBody>
-      </p:sp>
-      <p:sp>
-        <p:nvSpPr>
-          <p:cNvPr id="5" name="Shape 2"/>
-          <p:cNvSpPr/>
-          <p:nvPr/>
-        </p:nvSpPr>
-        <p:spPr>
-          <a:xfrm>
-            <a:off x="1546225" y="2064048"/>
-            <a:ext cx="9099550" cy="3746500"/>
-          </a:xfrm>
-          <a:prstGeom prst="roundRect">
-            <a:avLst>
-              <a:gd name="adj" fmla="val 2627"/>
-            </a:avLst>
-          </a:prstGeom>
-          <a:solidFill>
-            <a:srgbClr val="FFFFFF"/>
-          </a:solidFill>
-          <a:ln w="6350">
-            <a:solidFill>
-              <a:srgbClr val="E6E6E6"/>
-            </a:solidFill>
-            <a:prstDash val="solid"/>
-          </a:ln>
-        </p:spPr>
-      </p:sp>
-      <p:sp>
-        <p:nvSpPr>
-          <p:cNvPr id="6" name="Shape 3"/>
-          <p:cNvSpPr/>
-          <p:nvPr/>
-        </p:nvSpPr>
-        <p:spPr>
-          <a:xfrm>
-            <a:off x="1651000" y="2143423"/>
-            <a:ext cx="8890000" cy="3587750"/>
-          </a:xfrm>
-          <a:prstGeom prst="roundRect">
-            <a:avLst>
-              <a:gd name="adj" fmla="val 1416"/>
-            </a:avLst>
-          </a:prstGeom>
-          <a:solidFill>
-            <a:srgbClr val="FFFFFF"/>
-          </a:solidFill>
-          <a:ln/>
-        </p:spPr>
-      </p:sp>
-      <p:pic>
-        <p:nvPicPr>
-          <p:cNvPr id="7" name="Image 1" descr="The research plan's seven items: BioLangFusion reproduction and encoder swaps, LucaOne, half-life, translation efficiency, the mRFP control, structure features, and the distillation idea, each with its Gantt slot">    </p:cNvPr>
-          <p:cNvPicPr>
-            <a:picLocks noChangeAspect="1"/>
-          </p:cNvPicPr>
-          <p:nvPr/>
-        </p:nvPicPr>
-        <p:blipFill>
-          <a:blip r:embed="rId2"/>
-          <a:srcRect l="0" r="0" t="-62" b="-62"/>
-          <a:stretch/>
-        </p:blipFill>
-        <p:spPr>
-          <a:xfrm>
-            <a:off x="1651000" y="2143423"/>
-            <a:ext cx="8890000" cy="3587750"/>
-          </a:xfrm>
-          <a:prstGeom prst="roundRect">
-            <a:avLst>
-              <a:gd name="adj" fmla="val 1416"/>
-            </a:avLst>
-          </a:prstGeom>
-        </p:spPr>
-      </p:pic>
-      <p:sp>
-        <p:nvSpPr>
-          <p:cNvPr id="8" name="Text 4"/>
-          <p:cNvSpPr/>
-          <p:nvPr/>
-        </p:nvSpPr>
-        <p:spPr>
-          <a:xfrm>
-            <a:off x="812800" y="6024959"/>
-            <a:ext cx="10883392" cy="452041"/>
-          </a:xfrm>
-          <a:prstGeom prst="rect">
-            <a:avLst/>
-          </a:prstGeom>
-          <a:noFill/>
-          <a:ln/>
-        </p:spPr>
-        <p:txBody>
-          <a:bodyPr wrap="square" lIns="0" tIns="0" rIns="0" bIns="0" rtlCol="0" anchor="t">
-            <a:normAutofit/>
-          </a:bodyPr>
-          <a:lstStyle/>
-          <a:p>
-            <a:pPr algn="l" indent="0" marL="0">
-              <a:lnSpc>
-                <a:spcPts val="1680"/>
-              </a:lnSpc>
-              <a:buNone/>
-            </a:pPr>
-            <a:r>
-              <a:rPr lang="en-US" sz="1200" dirty="0">
-                <a:solidFill>
-                  <a:srgbClr val="615D59"/>
-                </a:solidFill>
-                <a:latin typeface="Inter" pitchFamily="34" charset="0"/>
-                <a:ea typeface="Inter" pitchFamily="34" charset="-122"/>
-                <a:cs typeface="Inter" pitchFamily="34" charset="-120"/>
-              </a:rPr>
-              <a:t>Nothing planned is replaced: Coupled Mamba stays the priority architecture, the tiers and ablations stand, the task set keeps its order. The items are carried out as the plan states them, under its own numbers.</a:t>
-            </a:r>
-            <a:endParaRPr lang="en-US" sz="1200" dirty="0"/>
-          </a:p>
-        </p:txBody>
-      </p:sp>
-    </p:spTree>
-  </p:cSld>
-  <p:clrMapOvr>
-    <a:masterClrMapping/>
-  </p:clrMapOvr>
-</p:sld>
-</file>
-
-<file path=ppt/slides/slide14.xml><?xml version="1.0" encoding="utf-8"?>
-<p:sld xmlns:a="http://schemas.openxmlformats.org/drawingml/2006/main" xmlns:r="http://schemas.openxmlformats.org/officeDocument/2006/relationships" xmlns:p="http://schemas.openxmlformats.org/presentationml/2006/main">
-  <p:cSld name="Slide 14">
-    <p:bg>
-      <p:bgPr>
-        <a:solidFill>
-          <a:srgbClr val="F6F5F4"/>
-        </a:solidFill>
-      </p:bgPr>
-    </p:bg>
-    <p:spTree>
-      <p:nvGrpSpPr>
-        <p:cNvPr id="1" name=""/>
-        <p:cNvGrpSpPr/>
-        <p:nvPr/>
-      </p:nvGrpSpPr>
-      <p:grpSpPr>
-        <a:xfrm>
-          <a:off x="0" y="0"/>
-          <a:ext cx="0" cy="0"/>
-          <a:chOff x="0" y="0"/>
-          <a:chExt cx="0" cy="0"/>
-        </a:xfrm>
-      </p:grpSpPr>
-      <p:pic>
-        <p:nvPicPr>
-          <p:cNvPr id="2" name="Image 0" descr="ellipse">    </p:cNvPr>
-          <p:cNvPicPr>
-            <a:picLocks noChangeAspect="1"/>
-          </p:cNvPicPr>
-          <p:nvPr/>
-        </p:nvPicPr>
-        <p:blipFill>
-          <a:blip r:embed="rId1"/>
-          <a:srcRect l="0" r="0" t="0" b="0"/>
-          <a:stretch/>
-        </p:blipFill>
-        <p:spPr>
-          <a:xfrm>
-            <a:off x="812800" y="862310"/>
-            <a:ext cx="114300" cy="114300"/>
-          </a:xfrm>
-          <a:prstGeom prst="rect">
-            <a:avLst/>
-          </a:prstGeom>
-        </p:spPr>
-      </p:pic>
-      <p:sp>
-        <p:nvSpPr>
-          <p:cNvPr id="3" name="Text 0"/>
-          <p:cNvSpPr/>
-          <p:nvPr/>
-        </p:nvSpPr>
-        <p:spPr>
-          <a:xfrm>
-            <a:off x="1003300" y="812800"/>
-            <a:ext cx="4694813" cy="238720"/>
-          </a:xfrm>
-          <a:prstGeom prst="rect">
-            <a:avLst/>
-          </a:prstGeom>
-          <a:noFill/>
-          <a:ln/>
-        </p:spPr>
-        <p:txBody>
-          <a:bodyPr wrap="square" lIns="0" tIns="0" rIns="0" bIns="0" rtlCol="0" anchor="t">
-            <a:normAutofit/>
-          </a:bodyPr>
-          <a:lstStyle/>
-          <a:p>
-            <a:pPr algn="l" indent="0" marL="0">
-              <a:lnSpc>
-                <a:spcPts val="1680"/>
-              </a:lnSpc>
-              <a:buNone/>
-            </a:pPr>
-            <a:r>
-              <a:rPr lang="en-US" sz="1200" b="1" dirty="0">
-                <a:solidFill>
-                  <a:srgbClr val="615D59"/>
-                </a:solidFill>
-                <a:latin typeface="Inter" pitchFamily="34" charset="0"/>
-                <a:ea typeface="Inter" pitchFamily="34" charset="-122"/>
-                <a:cs typeface="Inter" pitchFamily="34" charset="-120"/>
-              </a:rPr>
-              <a:t>Stages 3 and 4 · research plan item 1, Phases A and B</a:t>
-            </a:r>
-            <a:endParaRPr lang="en-US" sz="1200" dirty="0"/>
-          </a:p>
-        </p:txBody>
-      </p:sp>
-      <p:sp>
-        <p:nvSpPr>
-          <p:cNvPr id="4" name="Text 1"/>
-          <p:cNvSpPr/>
-          <p:nvPr>
-            <p:ph type="title"/>
-          </p:nvPr>
-        </p:nvSpPr>
-        <p:spPr>
-          <a:xfrm>
-            <a:off x="812800" y="1153120"/>
-            <a:ext cx="10883392" cy="806152"/>
-          </a:xfrm>
-          <a:prstGeom prst="rect">
-            <a:avLst/>
-          </a:prstGeom>
-          <a:noFill/>
-          <a:ln/>
-        </p:spPr>
-        <p:txBody>
-          <a:bodyPr wrap="square" lIns="0" tIns="0" rIns="0" bIns="0" rtlCol="0" anchor="t">
-            <a:normAutofit/>
-          </a:bodyPr>
-          <a:lstStyle/>
-          <a:p>
-            <a:pPr algn="l" indent="0" marL="0">
-              <a:lnSpc>
-                <a:spcPts val="3074"/>
-              </a:lnSpc>
-              <a:buNone/>
-            </a:pPr>
-            <a:r>
-              <a:rPr lang="en-US" sz="2900" b="1" i="0" spc="-100" kern="0" dirty="0">
-                <a:solidFill>
-                  <a:srgbClr val="000000"/>
-                </a:solidFill>
-                <a:latin typeface="Inter" pitchFamily="34" charset="0"/>
-                <a:ea typeface="Inter" pitchFamily="34" charset="-122"/>
-                <a:cs typeface="Inter" pitchFamily="34" charset="-120"/>
-              </a:rPr>
-              <a:t>Reproduce BioLangFusion exactly, then change the encoders and nothing else</a:t>
-            </a:r>
-            <a:endParaRPr lang="en-US" sz="2900" dirty="0"/>
-          </a:p>
-        </p:txBody>
-      </p:sp>
-      <p:sp>
-        <p:nvSpPr>
-          <p:cNvPr id="5" name="Shape 2"/>
-          <p:cNvSpPr/>
-          <p:nvPr/>
-        </p:nvSpPr>
-        <p:spPr>
-          <a:xfrm>
-            <a:off x="815975" y="2064048"/>
-            <a:ext cx="7296150" cy="3276600"/>
-          </a:xfrm>
-          <a:prstGeom prst="roundRect">
-            <a:avLst>
-              <a:gd name="adj" fmla="val 3004"/>
-            </a:avLst>
-          </a:prstGeom>
-          <a:solidFill>
-            <a:srgbClr val="FFFFFF"/>
-          </a:solidFill>
-          <a:ln w="6350">
-            <a:solidFill>
-              <a:srgbClr val="E6E6E6"/>
-            </a:solidFill>
-            <a:prstDash val="solid"/>
-          </a:ln>
-        </p:spPr>
-      </p:sp>
-      <p:sp>
-        <p:nvSpPr>
-          <p:cNvPr id="6" name="Shape 3"/>
-          <p:cNvSpPr/>
-          <p:nvPr/>
-        </p:nvSpPr>
-        <p:spPr>
-          <a:xfrm>
-            <a:off x="908050" y="2143423"/>
-            <a:ext cx="7112000" cy="3117850"/>
-          </a:xfrm>
-          <a:prstGeom prst="roundRect">
-            <a:avLst>
-              <a:gd name="adj" fmla="val 1629"/>
-            </a:avLst>
-          </a:prstGeom>
-          <a:solidFill>
-            <a:srgbClr val="FFFFFF"/>
-          </a:solidFill>
-          <a:ln/>
-        </p:spPr>
-      </p:sp>
-      <p:pic>
-        <p:nvPicPr>
-          <p:cNvPr id="7" name="Image 1" descr="The BioLangFusion architecture reproduced then run with swapped encoders; pooled or region-aware fusion where no grid exists; LucaOne and the Stage 3 designs it is compared with">    </p:cNvPr>
-          <p:cNvPicPr>
-            <a:picLocks noChangeAspect="1"/>
-          </p:cNvPicPr>
-          <p:nvPr/>
-        </p:nvPicPr>
-        <p:blipFill>
-          <a:blip r:embed="rId2"/>
-          <a:srcRect l="-23" r="-23" t="0" b="0"/>
-          <a:stretch/>
-        </p:blipFill>
-        <p:spPr>
-          <a:xfrm>
-            <a:off x="908050" y="2143423"/>
-            <a:ext cx="7112000" cy="3117850"/>
-          </a:xfrm>
-          <a:prstGeom prst="roundRect">
-            <a:avLst>
-              <a:gd name="adj" fmla="val 1629"/>
-            </a:avLst>
-          </a:prstGeom>
-        </p:spPr>
-      </p:pic>
-      <p:sp>
-        <p:nvSpPr>
-          <p:cNvPr id="8" name="Text 4"/>
-          <p:cNvSpPr/>
-          <p:nvPr/>
-        </p:nvSpPr>
-        <p:spPr>
-          <a:xfrm>
-            <a:off x="8270875" y="2064048"/>
-            <a:ext cx="3105150" cy="1136551"/>
-          </a:xfrm>
-          <a:prstGeom prst="roundRect">
-            <a:avLst>
-              <a:gd name="adj" fmla="val 6425"/>
-            </a:avLst>
-          </a:prstGeom>
-          <a:solidFill>
-            <a:srgbClr val="FFFFFF"/>
-          </a:solidFill>
-          <a:ln w="6350">
-            <a:solidFill>
-              <a:srgbClr val="E6E6E6"/>
-            </a:solidFill>
-            <a:prstDash val="solid"/>
-          </a:ln>
-        </p:spPr>
-        <p:txBody>
-          <a:bodyPr wrap="square" lIns="83387" tIns="57987" rIns="0" bIns="32587" rtlCol="0" anchor="t">
-            <a:normAutofit/>
-          </a:bodyPr>
-          <a:lstStyle/>
-          <a:p>
-            <a:pPr algn="l" indent="0" marL="0">
-              <a:lnSpc>
-                <a:spcPts val="1540"/>
-              </a:lnSpc>
-              <a:buNone/>
-            </a:pPr>
-            <a:r>
-              <a:rPr lang="en-US" sz="1100" b="1" dirty="0">
-                <a:solidFill>
-                  <a:srgbClr val="31302E"/>
-                </a:solidFill>
-                <a:latin typeface="Inter" pitchFamily="34" charset="0"/>
-                <a:ea typeface="Inter" pitchFamily="34" charset="-122"/>
-                <a:cs typeface="Inter" pitchFamily="34" charset="-120"/>
-              </a:rPr>
-              <a:t>Phase A, fixed:</a:t>
-            </a:r>
-            <a:r>
-              <a:rPr lang="en-US" sz="1100" dirty="0">
-                <a:solidFill>
-                  <a:srgbClr val="31302E"/>
-                </a:solidFill>
-                <a:latin typeface="Inter" pitchFamily="34" charset="0"/>
-                <a:ea typeface="Inter" pitchFamily="34" charset="-122"/>
-                <a:cs typeface="Inter" pitchFamily="34" charset="-120"/>
-              </a:rPr>
-              <a:t> NT v2 100M, RNA-FM, ESM-2 8M on the codon grid; the three heads; one TextCNN head; the CodonBERT splits and recipe; every unreported detail recorded as a deviation.</a:t>
-            </a:r>
-            <a:endParaRPr lang="en-US" sz="1100" dirty="0"/>
-          </a:p>
-        </p:txBody>
-      </p:sp>
-      <p:sp>
-        <p:nvSpPr>
-          <p:cNvPr id="9" name="Text 5"/>
-          <p:cNvSpPr/>
-          <p:nvPr/>
-        </p:nvSpPr>
-        <p:spPr>
-          <a:xfrm>
-            <a:off x="8270875" y="3283148"/>
-            <a:ext cx="3105150" cy="1136551"/>
-          </a:xfrm>
-          <a:prstGeom prst="roundRect">
-            <a:avLst>
-              <a:gd name="adj" fmla="val 6425"/>
-            </a:avLst>
-          </a:prstGeom>
-          <a:solidFill>
-            <a:srgbClr val="FFFFFF"/>
-          </a:solidFill>
-          <a:ln w="6350">
-            <a:solidFill>
-              <a:srgbClr val="E6E6E6"/>
-            </a:solidFill>
-            <a:prstDash val="solid"/>
-          </a:ln>
-        </p:spPr>
-        <p:txBody>
-          <a:bodyPr wrap="square" lIns="83387" tIns="57987" rIns="0" bIns="32587" rtlCol="0" anchor="t">
-            <a:normAutofit/>
-          </a:bodyPr>
-          <a:lstStyle/>
-          <a:p>
-            <a:pPr algn="l" indent="0" marL="0">
-              <a:lnSpc>
-                <a:spcPts val="1540"/>
-              </a:lnSpc>
-              <a:buNone/>
-            </a:pPr>
-            <a:r>
-              <a:rPr lang="en-US" sz="1100" b="1" dirty="0">
-                <a:solidFill>
-                  <a:srgbClr val="31302E"/>
-                </a:solidFill>
-                <a:latin typeface="Inter" pitchFamily="34" charset="0"/>
-                <a:ea typeface="Inter" pitchFamily="34" charset="-122"/>
-                <a:cs typeface="Inter" pitchFamily="34" charset="-120"/>
-              </a:rPr>
-              <a:t>Phase B, swapped one at a time:</a:t>
-            </a:r>
-            <a:r>
-              <a:rPr lang="en-US" sz="1100" dirty="0">
-                <a:solidFill>
-                  <a:srgbClr val="31302E"/>
-                </a:solidFill>
-                <a:latin typeface="Inter" pitchFamily="34" charset="0"/>
-                <a:ea typeface="Inter" pitchFamily="34" charset="-122"/>
-                <a:cs typeface="Inter" pitchFamily="34" charset="-120"/>
-              </a:rPr>
-              <a:t> CaLM or mRNA-FM for RNA-FM; ESM-2 150M or ProtBERT for ESM-2 8M; NT 500M, DNABERT-2, or HyenaDNA for NT v2. Then the promising triples.</a:t>
-            </a:r>
-            <a:endParaRPr lang="en-US" sz="1100" dirty="0"/>
-          </a:p>
-        </p:txBody>
-      </p:sp>
-      <p:sp>
-        <p:nvSpPr>
-          <p:cNvPr id="10" name="Text 6"/>
-          <p:cNvSpPr/>
-          <p:nvPr/>
-        </p:nvSpPr>
-        <p:spPr>
-          <a:xfrm>
-            <a:off x="8270875" y="4502249"/>
-            <a:ext cx="3105150" cy="1136551"/>
-          </a:xfrm>
-          <a:prstGeom prst="roundRect">
-            <a:avLst>
-              <a:gd name="adj" fmla="val 6425"/>
-            </a:avLst>
-          </a:prstGeom>
-          <a:solidFill>
-            <a:srgbClr val="FFFFFF"/>
-          </a:solidFill>
-          <a:ln w="6350">
-            <a:solidFill>
-              <a:srgbClr val="E6E6E6"/>
-            </a:solidFill>
-            <a:prstDash val="solid"/>
-          </a:ln>
-        </p:spPr>
-        <p:txBody>
-          <a:bodyPr wrap="square" lIns="83387" tIns="57987" rIns="0" bIns="32587" rtlCol="0" anchor="t">
-            <a:normAutofit/>
-          </a:bodyPr>
-          <a:lstStyle/>
-          <a:p>
-            <a:pPr algn="l" indent="0" marL="0">
-              <a:lnSpc>
-                <a:spcPts val="1540"/>
-              </a:lnSpc>
-              <a:buNone/>
-            </a:pPr>
-            <a:r>
-              <a:rPr lang="en-US" sz="1100" b="1" dirty="0">
-                <a:solidFill>
-                  <a:srgbClr val="31302E"/>
-                </a:solidFill>
-                <a:latin typeface="Inter" pitchFamily="34" charset="0"/>
-                <a:ea typeface="Inter" pitchFamily="34" charset="-122"/>
-                <a:cs typeface="Inter" pitchFamily="34" charset="-120"/>
-              </a:rPr>
-              <a:t>What it gives the plan:</a:t>
-            </a:r>
-            <a:r>
-              <a:rPr lang="en-US" sz="1100" dirty="0">
-                <a:solidFill>
-                  <a:srgbClr val="31302E"/>
-                </a:solidFill>
-                <a:latin typeface="Inter" pitchFamily="34" charset="0"/>
-                <a:ea typeface="Inter" pitchFamily="34" charset="-122"/>
-                <a:cs typeface="Inter" pitchFamily="34" charset="-120"/>
-              </a:rPr>
-              <a:t> a matched published baseline for Coupled Mamba on identical samples and splits, and the cleanest test of whether Stage 1 predicts which swaps gain (H2).</a:t>
-            </a:r>
-            <a:endParaRPr lang="en-US" sz="1100" dirty="0"/>
-          </a:p>
-        </p:txBody>
-      </p:sp>
-      <p:sp>
-        <p:nvSpPr>
-          <p:cNvPr id="11" name="Text 7"/>
-          <p:cNvSpPr/>
-          <p:nvPr/>
-        </p:nvSpPr>
-        <p:spPr>
-          <a:xfrm>
-            <a:off x="812800" y="6024959"/>
-            <a:ext cx="10883392" cy="452041"/>
-          </a:xfrm>
-          <a:prstGeom prst="rect">
-            <a:avLst/>
-          </a:prstGeom>
-          <a:noFill/>
-          <a:ln/>
-        </p:spPr>
-        <p:txBody>
-          <a:bodyPr wrap="square" lIns="0" tIns="0" rIns="0" bIns="0" rtlCol="0" anchor="t">
-            <a:normAutofit/>
-          </a:bodyPr>
-          <a:lstStyle/>
-          <a:p>
-            <a:pPr algn="l" indent="0" marL="0">
-              <a:lnSpc>
-                <a:spcPts val="1680"/>
-              </a:lnSpc>
-              <a:buNone/>
-            </a:pPr>
-            <a:r>
-              <a:rPr lang="en-US" sz="1200" dirty="0">
-                <a:solidFill>
-                  <a:srgbClr val="615D59"/>
-                </a:solidFill>
-                <a:latin typeface="Inter" pitchFamily="34" charset="0"/>
-                <a:ea typeface="Inter" pitchFamily="34" charset="-122"/>
-                <a:cs typeface="Inter" pitchFamily="34" charset="-120"/>
-              </a:rPr>
-              <a:t>The codon grid is positional alignment: a token-location operation, part of the reproduced system, not evidence that the embeddings carry the same information. Where no grid exists (GTEx, untranslated regions) fusion is pooled or region-aware.</a:t>
+              <a:t> Coupled Mamba (Gantt 20 to 21), then cross-attention (25), each scored against every baseline.</a:t>
             </a:r>
             <a:endParaRPr lang="en-US" sz="1200" dirty="0"/>
           </a:p>
@@ -6400,6 +6444,10 @@
             <a:prstDash val="solid"/>
           </a:ln>
         </p:spPr>
+        <p:txBody>
+          <a:bodyPr/>
+          <a:p/>
+        </p:txBody>
       </p:sp>
       <p:sp>
         <p:nvSpPr>
@@ -8610,6 +8658,10 @@
           </a:solidFill>
           <a:ln/>
         </p:spPr>
+        <p:txBody>
+          <a:bodyPr/>
+          <a:p/>
+        </p:txBody>
       </p:sp>
       <p:sp>
         <p:nvSpPr>
@@ -8725,6 +8777,10 @@
             <a:prstDash val="solid"/>
           </a:ln>
         </p:spPr>
+        <p:txBody>
+          <a:bodyPr/>
+          <a:p/>
+        </p:txBody>
       </p:sp>
       <p:sp>
         <p:nvSpPr>
@@ -8808,7 +8864,7 @@
                 <a:ea typeface="Inter" pitchFamily="34" charset="-122"/>
                 <a:cs typeface="Inter" pitchFamily="34" charset="-120"/>
               </a:rPr>
-              <a:t>Mean predictor · length and composition (GTEx: four length features, R² 0.242) · best single encoder · same-modality ensemble · concatenation + MLP · the reproduced BioLangFusion, LucaOne, and the published scores.</a:t>
+              <a:t>Mean predictor · length and composition (GTEx: four length features, R² 0.242) · best single encoder · same-modality ensemble · concatenation + MLP · the reproduced BioLangFusion and IsoFormer, LucaOne, and the published scores.</a:t>
             </a:r>
             <a:endParaRPr lang="en-US" sz="1150" dirty="0"/>
           </a:p>
@@ -8985,6 +9041,10 @@
             <a:prstDash val="solid"/>
           </a:ln>
         </p:spPr>
+        <p:txBody>
+          <a:bodyPr/>
+          <a:p/>
+        </p:txBody>
       </p:sp>
       <p:sp>
         <p:nvSpPr>
@@ -9007,6 +9067,10 @@
           </a:solidFill>
           <a:ln/>
         </p:spPr>
+        <p:txBody>
+          <a:bodyPr/>
+          <a:p/>
+        </p:txBody>
       </p:sp>
       <p:pic>
         <p:nvPicPr>
@@ -9494,6 +9558,10 @@
             <a:prstDash val="solid"/>
           </a:ln>
         </p:spPr>
+        <p:txBody>
+          <a:bodyPr/>
+          <a:p/>
+        </p:txBody>
       </p:sp>
       <p:sp>
         <p:nvSpPr>
@@ -10116,6 +10184,10 @@
           </a:solidFill>
           <a:ln/>
         </p:spPr>
+        <p:txBody>
+          <a:bodyPr/>
+          <a:p/>
+        </p:txBody>
       </p:sp>
       <p:sp>
         <p:nvSpPr>
@@ -10497,6 +10569,10 @@
             <a:prstDash val="solid"/>
           </a:ln>
         </p:spPr>
+        <p:txBody>
+          <a:bodyPr/>
+          <a:p/>
+        </p:txBody>
       </p:sp>
       <p:sp>
         <p:nvSpPr>
@@ -10536,7 +10612,7 @@
                 <a:ea typeface="Inter" pitchFamily="34" charset="-122"/>
                 <a:cs typeface="Inter" pitchFamily="34" charset="-120"/>
               </a:rPr>
-              <a:t>The Gantt chart, seven items folded in</a:t>
+              <a:t>Her plan first, then our designs</a:t>
             </a:r>
             <a:endParaRPr lang="en-US" sz="1500" dirty="0"/>
           </a:p>
@@ -10604,7 +10680,7 @@
                 <a:ea typeface="Inter" pitchFamily="34" charset="-122"/>
                 <a:cs typeface="Inter" pitchFamily="34" charset="-120"/>
               </a:rPr>
-              <a:t>Coupled Mamba feasibility (20) in parallel, then evaluated against the reproduced heads on identical splits (21)</a:t>
+              <a:t>Encoder swaps right after the reproduction (24, now planned), then LucaOne (41) and IsoFormer on GTEx (44)</a:t>
             </a:r>
             <a:endParaRPr lang="en-US" sz="1250" dirty="0"/>
           </a:p>
@@ -10626,7 +10702,7 @@
                 <a:ea typeface="Inter" pitchFamily="34" charset="-122"/>
                 <a:cs typeface="Inter" pitchFamily="34" charset="-120"/>
               </a:rPr>
-              <a:t>Encoder swaps right after the reproduction (24, now planned), then the LucaOne frozen baseline (41); the alignment-loss ablation (23)</a:t>
+              <a:t>Half-life and translation efficiency after the gates (42, by December 20); repeated runs (28); synthesis (29)</a:t>
             </a:r>
             <a:endParaRPr lang="en-US" sz="1250" dirty="0"/>
           </a:p>
@@ -10648,7 +10724,7 @@
                 <a:ea typeface="Inter" pitchFamily="34" charset="-122"/>
                 <a:cs typeface="Inter" pitchFamily="34" charset="-120"/>
               </a:rPr>
-              <a:t>Cross-attention on GTEx (25, conditional); repeated runs and uncertainty (28); synthesis (29)</a:t>
+              <a:t>From January: Coupled Mamba (20, 21), then cross-attention (25), against every baseline; the alignment-loss ablation (23)</a:t>
             </a:r>
             <a:endParaRPr lang="en-US" sz="1250" dirty="0"/>
           </a:p>
@@ -10670,7 +10746,7 @@
                 <a:ea typeface="Inter" pitchFamily="34" charset="-122"/>
                 <a:cs typeface="Inter" pitchFamily="34" charset="-120"/>
               </a:rPr>
-              <a:t>Half-life and translation efficiency after the gates (42); structure (38); distillation (43); all conditional, January to February</a:t>
+              <a:t>March, conditional: structure (38) and distillation (43)</a:t>
             </a:r>
             <a:endParaRPr lang="en-US" sz="1250" dirty="0"/>
           </a:p>
@@ -10697,6 +10773,10 @@
           </a:solidFill>
           <a:ln/>
         </p:spPr>
+        <p:txBody>
+          <a:bodyPr/>
+          <a:p/>
+        </p:txBody>
       </p:sp>
       <p:sp>
         <p:nvSpPr>
@@ -10826,7 +10906,7 @@
                 <a:ea typeface="Inter" pitchFamily="34" charset="-122"/>
                 <a:cs typeface="Inter" pitchFamily="34" charset="-120"/>
               </a:rPr>
-              <a:t>Your seven items in your order: ID 17 widened to the five published datasets, then the swaps (24), then LucaOne (41); half-life and translation efficiency in ID 42. Does that timing work?</a:t>
+              <a:t>Your list first: the reproduction (17), the swaps (24), LucaOne and IsoFormer (41, 44), half-life and translation efficiency (42) by December 20; our designs from January. Does that order work?</a:t>
             </a:r>
             <a:endParaRPr lang="en-US" sz="1242" dirty="0"/>
           </a:p>
@@ -11047,6 +11127,10 @@
             <a:prstDash val="solid"/>
           </a:ln>
         </p:spPr>
+        <p:txBody>
+          <a:bodyPr/>
+          <a:p/>
+        </p:txBody>
       </p:sp>
       <p:sp>
         <p:nvSpPr>
@@ -11069,6 +11153,10 @@
           </a:solidFill>
           <a:ln/>
         </p:spPr>
+        <p:txBody>
+          <a:bodyPr/>
+          <a:p/>
+        </p:txBody>
       </p:sp>
       <p:pic>
         <p:nvPicPr>
@@ -11310,6 +11398,10 @@
             <a:prstDash val="solid"/>
           </a:ln>
         </p:spPr>
+        <p:txBody>
+          <a:bodyPr/>
+          <a:p/>
+        </p:txBody>
       </p:sp>
       <p:sp>
         <p:nvSpPr>
@@ -11332,6 +11424,10 @@
           </a:solidFill>
           <a:ln/>
         </p:spPr>
+        <p:txBody>
+          <a:bodyPr/>
+          <a:p/>
+        </p:txBody>
       </p:sp>
       <p:pic>
         <p:nvPicPr>
@@ -11573,6 +11669,10 @@
             <a:prstDash val="solid"/>
           </a:ln>
         </p:spPr>
+        <p:txBody>
+          <a:bodyPr/>
+          <a:p/>
+        </p:txBody>
       </p:sp>
       <p:sp>
         <p:nvSpPr>
@@ -11595,6 +11695,10 @@
           </a:solidFill>
           <a:ln/>
         </p:spPr>
+        <p:txBody>
+          <a:bodyPr/>
+          <a:p/>
+        </p:txBody>
       </p:sp>
       <p:pic>
         <p:nvPicPr>
@@ -11647,6 +11751,10 @@
             <a:prstDash val="solid"/>
           </a:ln>
         </p:spPr>
+        <p:txBody>
+          <a:bodyPr/>
+          <a:p/>
+        </p:txBody>
       </p:sp>
       <p:sp>
         <p:nvSpPr>
@@ -11762,6 +11870,10 @@
             <a:prstDash val="solid"/>
           </a:ln>
         </p:spPr>
+        <p:txBody>
+          <a:bodyPr/>
+          <a:p/>
+        </p:txBody>
       </p:sp>
       <p:sp>
         <p:nvSpPr>
@@ -12066,6 +12178,10 @@
             <a:prstDash val="solid"/>
           </a:ln>
         </p:spPr>
+        <p:txBody>
+          <a:bodyPr/>
+          <a:p/>
+        </p:txBody>
       </p:sp>
       <p:sp>
         <p:nvSpPr>
@@ -12088,6 +12204,10 @@
           </a:solidFill>
           <a:ln/>
         </p:spPr>
+        <p:txBody>
+          <a:bodyPr/>
+          <a:p/>
+        </p:txBody>
       </p:sp>
       <p:pic>
         <p:nvPicPr>
@@ -12140,6 +12260,10 @@
             <a:prstDash val="solid"/>
           </a:ln>
         </p:spPr>
+        <p:txBody>
+          <a:bodyPr/>
+          <a:p/>
+        </p:txBody>
       </p:sp>
       <p:sp>
         <p:nvSpPr>
@@ -12255,6 +12379,10 @@
             <a:prstDash val="solid"/>
           </a:ln>
         </p:spPr>
+        <p:txBody>
+          <a:bodyPr/>
+          <a:p/>
+        </p:txBody>
       </p:sp>
       <p:sp>
         <p:nvSpPr>
@@ -12559,6 +12687,10 @@
             <a:prstDash val="solid"/>
           </a:ln>
         </p:spPr>
+        <p:txBody>
+          <a:bodyPr/>
+          <a:p/>
+        </p:txBody>
       </p:sp>
       <p:sp>
         <p:nvSpPr>
@@ -12581,6 +12713,10 @@
           </a:solidFill>
           <a:ln/>
         </p:spPr>
+        <p:txBody>
+          <a:bodyPr/>
+          <a:p/>
+        </p:txBody>
       </p:sp>
       <p:pic>
         <p:nvPicPr>
@@ -12633,6 +12769,10 @@
             <a:prstDash val="solid"/>
           </a:ln>
         </p:spPr>
+        <p:txBody>
+          <a:bodyPr/>
+          <a:p/>
+        </p:txBody>
       </p:sp>
       <p:sp>
         <p:nvSpPr>
@@ -12748,6 +12888,10 @@
             <a:prstDash val="solid"/>
           </a:ln>
         </p:spPr>
+        <p:txBody>
+          <a:bodyPr/>
+          <a:p/>
+        </p:txBody>
       </p:sp>
       <p:sp>
         <p:nvSpPr>
@@ -13052,6 +13196,10 @@
             <a:prstDash val="solid"/>
           </a:ln>
         </p:spPr>
+        <p:txBody>
+          <a:bodyPr/>
+          <a:p/>
+        </p:txBody>
       </p:sp>
       <p:sp>
         <p:nvSpPr>
@@ -13074,6 +13222,10 @@
           </a:solidFill>
           <a:ln/>
         </p:spPr>
+        <p:txBody>
+          <a:bodyPr/>
+          <a:p/>
+        </p:txBody>
       </p:sp>
       <p:pic>
         <p:nvPicPr>
@@ -13126,6 +13278,10 @@
             <a:prstDash val="solid"/>
           </a:ln>
         </p:spPr>
+        <p:txBody>
+          <a:bodyPr/>
+          <a:p/>
+        </p:txBody>
       </p:sp>
       <p:sp>
         <p:nvSpPr>
@@ -13241,6 +13397,10 @@
             <a:prstDash val="solid"/>
           </a:ln>
         </p:spPr>
+        <p:txBody>
+          <a:bodyPr/>
+          <a:p/>
+        </p:txBody>
       </p:sp>
       <p:sp>
         <p:nvSpPr>
@@ -13519,6 +13679,10 @@
           </a:solidFill>
           <a:ln/>
         </p:spPr>
+        <p:txBody>
+          <a:bodyPr/>
+          <a:p/>
+        </p:txBody>
       </p:sp>
       <p:sp>
         <p:nvSpPr>
@@ -13629,6 +13793,10 @@
           </a:solidFill>
           <a:ln/>
         </p:spPr>
+        <p:txBody>
+          <a:bodyPr/>
+          <a:p/>
+        </p:txBody>
       </p:sp>
       <p:sp>
         <p:nvSpPr>
@@ -13889,6 +14057,10 @@
             <a:prstDash val="solid"/>
           </a:ln>
         </p:spPr>
+        <p:txBody>
+          <a:bodyPr/>
+          <a:p/>
+        </p:txBody>
       </p:sp>
       <p:sp>
         <p:nvSpPr>
@@ -13911,6 +14083,10 @@
           </a:solidFill>
           <a:ln/>
         </p:spPr>
+        <p:txBody>
+          <a:bodyPr/>
+          <a:p/>
+        </p:txBody>
       </p:sp>
       <p:pic>
         <p:nvPicPr>

</xml_diff>